<commit_message>
summary slides without speaker notes
</commit_message>
<xml_diff>
--- a/output/summary_slides.pptx
+++ b/output/summary_slides.pptx
@@ -1629,356 +1629,6 @@
 </p:notesMaster>
 </file>
 
-<file path=ppt/notesSlides/notesSlide1.xml><?xml version="1.0" encoding="utf-8"?>
-<p:notes xmlns:a="http://schemas.openxmlformats.org/drawingml/2006/main" xmlns:p="http://schemas.openxmlformats.org/presentationml/2006/main" xmlns:r="http://schemas.openxmlformats.org/officeDocument/2006/relationships">
-  <p:cSld>
-    <p:spTree>
-      <p:nvGrpSpPr>
-        <p:cNvPr id="1" name=""/>
-        <p:cNvGrpSpPr/>
-        <p:nvPr/>
-      </p:nvGrpSpPr>
-      <p:grpSpPr>
-        <a:xfrm>
-          <a:off x="0" y="0"/>
-          <a:ext cx="0" cy="0"/>
-          <a:chOff x="0" y="0"/>
-          <a:chExt cx="0" cy="0"/>
-        </a:xfrm>
-      </p:grpSpPr>
-      <p:sp>
-        <p:nvSpPr>
-          <p:cNvPr id="2" name="Slide Image Placeholder 1"/>
-          <p:cNvSpPr>
-            <a:spLocks noGrp="1"/>
-          </p:cNvSpPr>
-          <p:nvPr>
-            <p:ph type="sldImg" idx="2"/>
-          </p:nvPr>
-        </p:nvSpPr>
-        <p:spPr/>
-      </p:sp>
-      <p:sp>
-        <p:nvSpPr>
-          <p:cNvPr id="3" name="Notes Placeholder 2"/>
-          <p:cNvSpPr>
-            <a:spLocks noGrp="1"/>
-          </p:cNvSpPr>
-          <p:nvPr>
-            <p:ph type="body" idx="3" sz="quarter"/>
-          </p:nvPr>
-        </p:nvSpPr>
-        <p:spPr/>
-        <p:txBody>
-          <a:bodyPr/>
-          <a:lstStyle/>
-          <a:p>
-            <a:r>
-              <a:t>Each part at each site is one pair, 340 in all. WOS divides today's stock by the average weekly demand over Nov to Jan, the demand this stock will actually meet. The GDC's demand includes the restock it ships to the PDCs, because that leaves its shelf just like a sale. Short is under 4 weeks, about one restock cycle. Excess is over 26 weeks. I report a status mix per site instead of one WOS number, because an average hides shortages behind excess. Details: ASSUMPTIONS.md 5.2 to 5.4.</a:t>
-            </a:r>
-          </a:p>
-        </p:txBody>
-      </p:sp>
-      <p:sp>
-        <p:nvSpPr>
-          <p:cNvPr id="4" name="Slide Number Placeholder 3"/>
-          <p:cNvSpPr>
-            <a:spLocks noGrp="1"/>
-          </p:cNvSpPr>
-          <p:nvPr>
-            <p:ph type="sldNum" idx="5" sz="quarter"/>
-          </p:nvPr>
-        </p:nvSpPr>
-        <p:spPr/>
-      </p:sp>
-    </p:spTree>
-  </p:cSld>
-  <p:clrMapOvr>
-    <a:masterClrMapping/>
-  </p:clrMapOvr>
-</p:notes>
-</file>
-
-<file path=ppt/notesSlides/notesSlide2.xml><?xml version="1.0" encoding="utf-8"?>
-<p:notes xmlns:a="http://schemas.openxmlformats.org/drawingml/2006/main" xmlns:p="http://schemas.openxmlformats.org/presentationml/2006/main" xmlns:r="http://schemas.openxmlformats.org/officeDocument/2006/relationships">
-  <p:cSld>
-    <p:spTree>
-      <p:nvGrpSpPr>
-        <p:cNvPr id="1" name=""/>
-        <p:cNvGrpSpPr/>
-        <p:nvPr/>
-      </p:nvGrpSpPr>
-      <p:grpSpPr>
-        <a:xfrm>
-          <a:off x="0" y="0"/>
-          <a:ext cx="0" cy="0"/>
-          <a:chOff x="0" y="0"/>
-          <a:chExt cx="0" cy="0"/>
-        </a:xfrm>
-      </p:grpSpPr>
-      <p:sp>
-        <p:nvSpPr>
-          <p:cNvPr id="2" name="Slide Image Placeholder 1"/>
-          <p:cNvSpPr>
-            <a:spLocks noGrp="1"/>
-          </p:cNvSpPr>
-          <p:nvPr>
-            <p:ph type="sldImg" idx="2"/>
-          </p:nvPr>
-        </p:nvSpPr>
-        <p:spPr/>
-      </p:sp>
-      <p:sp>
-        <p:nvSpPr>
-          <p:cNvPr id="3" name="Notes Placeholder 2"/>
-          <p:cNvSpPr>
-            <a:spLocks noGrp="1"/>
-          </p:cNvSpPr>
-          <p:nvPr>
-            <p:ph type="body" idx="3" sz="quarter"/>
-          </p:nvPr>
-        </p:nvSpPr>
-        <p:spPr/>
-        <p:txBody>
-          <a:bodyPr/>
-          <a:lstStyle/>
-          <a:p>
-            <a:r>
-              <a:t>The projection runs day by day to Jan 31. Customers buy every day, POs land on their ETA, and planned restock leaves the GDC on the 1st of each month, but only if the GDC has the stock. That last rule is why the GDC jumps: it keeps shipping to the PDCs and runs dry. The data has no order dates, so the projection assumes no new order lands before Jan 31. Details: ASSUMPTIONS.md 5.5.</a:t>
-            </a:r>
-          </a:p>
-        </p:txBody>
-      </p:sp>
-      <p:sp>
-        <p:nvSpPr>
-          <p:cNvPr id="4" name="Slide Number Placeholder 3"/>
-          <p:cNvSpPr>
-            <a:spLocks noGrp="1"/>
-          </p:cNvSpPr>
-          <p:nvPr>
-            <p:ph type="sldNum" idx="5" sz="quarter"/>
-          </p:nvPr>
-        </p:nvSpPr>
-        <p:spPr/>
-      </p:sp>
-    </p:spTree>
-  </p:cSld>
-  <p:clrMapOvr>
-    <a:masterClrMapping/>
-  </p:clrMapOvr>
-</p:notes>
-</file>
-
-<file path=ppt/notesSlides/notesSlide3.xml><?xml version="1.0" encoding="utf-8"?>
-<p:notes xmlns:a="http://schemas.openxmlformats.org/drawingml/2006/main" xmlns:p="http://schemas.openxmlformats.org/presentationml/2006/main" xmlns:r="http://schemas.openxmlformats.org/officeDocument/2006/relationships">
-  <p:cSld>
-    <p:spTree>
-      <p:nvGrpSpPr>
-        <p:cNvPr id="1" name=""/>
-        <p:cNvGrpSpPr/>
-        <p:nvPr/>
-      </p:nvGrpSpPr>
-      <p:grpSpPr>
-        <a:xfrm>
-          <a:off x="0" y="0"/>
-          <a:ext cx="0" cy="0"/>
-          <a:chOff x="0" y="0"/>
-          <a:chExt cx="0" cy="0"/>
-        </a:xfrm>
-      </p:grpSpPr>
-      <p:sp>
-        <p:nvSpPr>
-          <p:cNvPr id="2" name="Slide Image Placeholder 1"/>
-          <p:cNvSpPr>
-            <a:spLocks noGrp="1"/>
-          </p:cNvSpPr>
-          <p:nvPr>
-            <p:ph type="sldImg" idx="2"/>
-          </p:nvPr>
-        </p:nvSpPr>
-        <p:spPr/>
-      </p:sp>
-      <p:sp>
-        <p:nvSpPr>
-          <p:cNvPr id="3" name="Notes Placeholder 2"/>
-          <p:cNvSpPr>
-            <a:spLocks noGrp="1"/>
-          </p:cNvSpPr>
-          <p:nvPr>
-            <p:ph type="body" idx="3" sz="quarter"/>
-          </p:nvPr>
-        </p:nvSpPr>
-        <p:spPr/>
-        <p:txBody>
-          <a:bodyPr/>
-          <a:lstStyle/>
-          <a:p>
-            <a:r>
-              <a:t>These come straight from the action columns in the workbook: gdc_shortfalls, supply_review_lines and stock_moves. The first is the biggest risk, because nothing is on the way. The data has no lead times, and open supply lands up to 12 weeks out, so orders placed now may not land before Jan 31. That makes the moves and expedites the fastest fixes. SKU98 is the worked example in the dashboard.</a:t>
-            </a:r>
-          </a:p>
-        </p:txBody>
-      </p:sp>
-      <p:sp>
-        <p:nvSpPr>
-          <p:cNvPr id="4" name="Slide Number Placeholder 3"/>
-          <p:cNvSpPr>
-            <a:spLocks noGrp="1"/>
-          </p:cNvSpPr>
-          <p:nvPr>
-            <p:ph type="sldNum" idx="5" sz="quarter"/>
-          </p:nvPr>
-        </p:nvSpPr>
-        <p:spPr/>
-      </p:sp>
-    </p:spTree>
-  </p:cSld>
-  <p:clrMapOvr>
-    <a:masterClrMapping/>
-  </p:clrMapOvr>
-</p:notes>
-</file>
-
-<file path=ppt/notesSlides/notesSlide4.xml><?xml version="1.0" encoding="utf-8"?>
-<p:notes xmlns:a="http://schemas.openxmlformats.org/drawingml/2006/main" xmlns:p="http://schemas.openxmlformats.org/presentationml/2006/main" xmlns:r="http://schemas.openxmlformats.org/officeDocument/2006/relationships">
-  <p:cSld>
-    <p:spTree>
-      <p:nvGrpSpPr>
-        <p:cNvPr id="1" name=""/>
-        <p:cNvGrpSpPr/>
-        <p:nvPr/>
-      </p:nvGrpSpPr>
-      <p:grpSpPr>
-        <a:xfrm>
-          <a:off x="0" y="0"/>
-          <a:ext cx="0" cy="0"/>
-          <a:chOff x="0" y="0"/>
-          <a:chExt cx="0" cy="0"/>
-        </a:xfrm>
-      </p:grpSpPr>
-      <p:sp>
-        <p:nvSpPr>
-          <p:cNvPr id="2" name="Slide Image Placeholder 1"/>
-          <p:cNvSpPr>
-            <a:spLocks noGrp="1"/>
-          </p:cNvSpPr>
-          <p:nvPr>
-            <p:ph type="sldImg" idx="2"/>
-          </p:nvPr>
-        </p:nvSpPr>
-        <p:spPr/>
-      </p:sp>
-      <p:sp>
-        <p:nvSpPr>
-          <p:cNvPr id="3" name="Notes Placeholder 2"/>
-          <p:cNvSpPr>
-            <a:spLocks noGrp="1"/>
-          </p:cNvSpPr>
-          <p:nvPr>
-            <p:ph type="body" idx="3" sz="quarter"/>
-          </p:nvPr>
-        </p:nvSpPr>
-        <p:spPr/>
-        <p:txBody>
-          <a:bodyPr/>
-          <a:lstStyle/>
-          <a:p>
-            <a:r>
-              <a:t>Pallet equivalents put bolts and windshields on one scale of space: pieces divided by pieces per pallet, part by part. Excess counts only the stock above the 26-week line, not the whole pair. Dead stock has no demand anywhere in the network for 24 months. SKU901 and SKU902 aren't called dead stock, because they may be typos of known parts. Details: ASSUMPTIONS.md 4.10, 5.3 to 5.5.</a:t>
-            </a:r>
-          </a:p>
-        </p:txBody>
-      </p:sp>
-      <p:sp>
-        <p:nvSpPr>
-          <p:cNvPr id="4" name="Slide Number Placeholder 3"/>
-          <p:cNvSpPr>
-            <a:spLocks noGrp="1"/>
-          </p:cNvSpPr>
-          <p:nvPr>
-            <p:ph type="sldNum" idx="5" sz="quarter"/>
-          </p:nvPr>
-        </p:nvSpPr>
-        <p:spPr/>
-      </p:sp>
-    </p:spTree>
-  </p:cSld>
-  <p:clrMapOvr>
-    <a:masterClrMapping/>
-  </p:clrMapOvr>
-</p:notes>
-</file>
-
-<file path=ppt/notesSlides/notesSlide5.xml><?xml version="1.0" encoding="utf-8"?>
-<p:notes xmlns:a="http://schemas.openxmlformats.org/drawingml/2006/main" xmlns:p="http://schemas.openxmlformats.org/presentationml/2006/main" xmlns:r="http://schemas.openxmlformats.org/officeDocument/2006/relationships">
-  <p:cSld>
-    <p:spTree>
-      <p:nvGrpSpPr>
-        <p:cNvPr id="1" name=""/>
-        <p:cNvGrpSpPr/>
-        <p:nvPr/>
-      </p:nvGrpSpPr>
-      <p:grpSpPr>
-        <a:xfrm>
-          <a:off x="0" y="0"/>
-          <a:ext cx="0" cy="0"/>
-          <a:chOff x="0" y="0"/>
-          <a:chExt cx="0" cy="0"/>
-        </a:xfrm>
-      </p:grpSpPr>
-      <p:sp>
-        <p:nvSpPr>
-          <p:cNvPr id="2" name="Slide Image Placeholder 1"/>
-          <p:cNvSpPr>
-            <a:spLocks noGrp="1"/>
-          </p:cNvSpPr>
-          <p:nvPr>
-            <p:ph type="sldImg" idx="2"/>
-          </p:nvPr>
-        </p:nvSpPr>
-        <p:spPr/>
-      </p:sp>
-      <p:sp>
-        <p:nvSpPr>
-          <p:cNvPr id="3" name="Notes Placeholder 2"/>
-          <p:cNvSpPr>
-            <a:spLocks noGrp="1"/>
-          </p:cNvSpPr>
-          <p:nvPr>
-            <p:ph type="body" idx="3" sz="quarter"/>
-          </p:nvPr>
-        </p:nvSpPr>
-        <p:spPr/>
-        <p:txBody>
-          <a:bodyPr/>
-          <a:lstStyle/>
-          <a:p>
-            <a:r>
-              <a:t>Every odd value in the raw files has a flag, with what it might mean, in the flags sheet of the workbook. These four move the numbers most. Nothing was dropped or changed silently: only exact copies were dropped, and look-alike PO lines are all kept until the buyer confirms. Details: ASSUMPTIONS.md sections 3 and 4.</a:t>
-            </a:r>
-          </a:p>
-        </p:txBody>
-      </p:sp>
-      <p:sp>
-        <p:nvSpPr>
-          <p:cNvPr id="4" name="Slide Number Placeholder 3"/>
-          <p:cNvSpPr>
-            <a:spLocks noGrp="1"/>
-          </p:cNvSpPr>
-          <p:nvPr>
-            <p:ph type="sldNum" idx="5" sz="quarter"/>
-          </p:nvPr>
-        </p:nvSpPr>
-        <p:spPr/>
-      </p:sp>
-    </p:spTree>
-  </p:cSld>
-  <p:clrMapOvr>
-    <a:masterClrMapping/>
-  </p:clrMapOvr>
-</p:notes>
-</file>
-
 <file path=ppt/slideLayouts/slideLayout1.xml><?xml version="1.0" encoding="utf-8"?>
 <p:sldLayout xmlns:a="http://schemas.openxmlformats.org/drawingml/2006/main" xmlns:r="http://schemas.openxmlformats.org/officeDocument/2006/relationships" xmlns:p="http://schemas.openxmlformats.org/presentationml/2006/main" type="title" preserve="1">
   <p:cSld name="Title Slide">

</xml_diff>

<commit_message>
final review: fix docs, slide links and requirements
- README: the deck has no speaker notes, run_pipeline.py builds the tables
  and chart, and inventory_health.csv keeps columns the sheet leaves out
- ASSUMPTIONS 5.6 and the agent: describe the design only, no test results
- summary slides: the app and GitHub links on slide 5 work anywhere on the
  chip, and the file statistics match the deck
- requirements: drop ipykernel, the notebook is gone
- neutral wording in the theme comments
</commit_message>
<xml_diff>
--- a/output/summary_slides.pptx
+++ b/output/summary_slides.pptx
@@ -11409,7 +11409,7 @@
       <p:sp>
         <p:nvSpPr>
           <p:cNvPr id="32" name="Rounded Rectangle 31">
-            <a:hlinkClick r:id="rId9"/>
+            <a:hlinkClick r:id="rId10"/>
           </p:cNvPr>
           <p:cNvSpPr/>
           <p:nvPr/>
@@ -11458,14 +11458,16 @@
       </p:sp>
       <p:pic>
         <p:nvPicPr>
-          <p:cNvPr id="33" name="Picture 32" descr="image.png"/>
+          <p:cNvPr id="33" name="Picture 32" descr="image.png">
+            <a:hlinkClick r:id="rId10"/>
+          </p:cNvPr>
           <p:cNvPicPr>
             <a:picLocks noChangeAspect="1"/>
           </p:cNvPicPr>
           <p:nvPr/>
         </p:nvPicPr>
         <p:blipFill>
-          <a:blip r:embed="rId10"/>
+          <a:blip r:embed="rId9"/>
           <a:stretch>
             <a:fillRect/>
           </a:stretch>
@@ -11482,7 +11484,9 @@
       </p:pic>
       <p:sp>
         <p:nvSpPr>
-          <p:cNvPr id="34" name="TextBox 33"/>
+          <p:cNvPr id="34" name="TextBox 33">
+            <a:hlinkClick r:id="rId10"/>
+          </p:cNvPr>
           <p:cNvSpPr txBox="1"/>
           <p:nvPr/>
         </p:nvSpPr>
@@ -11522,7 +11526,7 @@
       <p:sp>
         <p:nvSpPr>
           <p:cNvPr id="35" name="Rounded Rectangle 34">
-            <a:hlinkClick r:id="rId11"/>
+            <a:hlinkClick r:id="rId12"/>
           </p:cNvPr>
           <p:cNvSpPr/>
           <p:nvPr/>
@@ -11571,14 +11575,16 @@
       </p:sp>
       <p:pic>
         <p:nvPicPr>
-          <p:cNvPr id="36" name="Picture 35" descr="image.png"/>
+          <p:cNvPr id="36" name="Picture 35" descr="image.png">
+            <a:hlinkClick r:id="rId12"/>
+          </p:cNvPr>
           <p:cNvPicPr>
             <a:picLocks noChangeAspect="1"/>
           </p:cNvPicPr>
           <p:nvPr/>
         </p:nvPicPr>
         <p:blipFill>
-          <a:blip r:embed="rId12"/>
+          <a:blip r:embed="rId11"/>
           <a:stretch>
             <a:fillRect/>
           </a:stretch>
@@ -11595,7 +11601,9 @@
       </p:pic>
       <p:sp>
         <p:nvSpPr>
-          <p:cNvPr id="37" name="TextBox 36"/>
+          <p:cNvPr id="37" name="TextBox 36">
+            <a:hlinkClick r:id="rId12"/>
+          </p:cNvPr>
           <p:cNvSpPr txBox="1"/>
           <p:nvPr/>
         </p:nvSpPr>

</xml_diff>